<commit_message>
Designer-sprint deck: alle vijf slides
Co-Authored-By: Claude Opus 5.5 <noreply@anthropic.com>
Claude-Session: https://claude.ai/code/session_01AoQDvxgMDPBEGoQsu7Fjuh
</commit_message>
<xml_diff>
--- a/Platform/designer-sprint/deck/designer-voorstellen-bewerkbaar.pptx
+++ b/Platform/designer-sprint/deck/designer-voorstellen-bewerkbaar.pptx
@@ -6,6 +6,10 @@
   </p:sldMasterIdLst>
   <p:sldIdLst>
     <p:sldId id="256" r:id="rId7"/>
+    <p:sldId id="257" r:id="rId8"/>
+    <p:sldId id="258" r:id="rId9"/>
+    <p:sldId id="259" r:id="rId10"/>
+    <p:sldId id="260" r:id="rId11"/>
   </p:sldIdLst>
   <p:sldSz cx="12192000" cy="6858000" type="screen4x3"/>
   <p:notesSz cx="6858000" cy="9144000"/>
@@ -3090,6 +3094,1063 @@
       <p:grpSpPr/>
       <p:sp>
         <p:nvSpPr>
+          <p:cNvPr id="2" name="Rectangle 1"/>
+          <p:cNvSpPr/>
+          <p:nvPr/>
+        </p:nvSpPr>
+        <p:spPr>
+          <a:xfrm>
+            <a:off x="0" y="0"/>
+            <a:ext cx="12192000" cy="6858000"/>
+          </a:xfrm>
+          <a:prstGeom prst="rect">
+            <a:avLst/>
+          </a:prstGeom>
+          <a:solidFill>
+            <a:srgbClr val="002333"/>
+          </a:solidFill>
+          <a:ln>
+            <a:noFill/>
+          </a:ln>
+          <a:effectLst/>
+        </p:spPr>
+        <p:style>
+          <a:lnRef idx="1">
+            <a:schemeClr val="accent1"/>
+          </a:lnRef>
+          <a:fillRef idx="3">
+            <a:schemeClr val="accent1"/>
+          </a:fillRef>
+          <a:effectRef idx="2">
+            <a:schemeClr val="accent1"/>
+          </a:effectRef>
+          <a:fontRef idx="minor">
+            <a:schemeClr val="lt1"/>
+          </a:fontRef>
+        </p:style>
+        <p:txBody>
+          <a:bodyPr rtlCol="0" anchor="ctr"/>
+          <a:lstStyle/>
+          <a:p>
+            <a:pPr algn="ctr"/>
+          </a:p>
+        </p:txBody>
+      </p:sp>
+      <p:sp>
+        <p:nvSpPr>
+          <p:cNvPr id="3" name="TextBox 2"/>
+          <p:cNvSpPr txBox="1"/>
+          <p:nvPr/>
+        </p:nvSpPr>
+        <p:spPr>
+          <a:xfrm>
+            <a:off x="762000" y="1587500"/>
+            <a:ext cx="6096000" cy="254000"/>
+          </a:xfrm>
+          <a:prstGeom prst="rect">
+            <a:avLst/>
+          </a:prstGeom>
+          <a:noFill/>
+        </p:spPr>
+        <p:txBody>
+          <a:bodyPr wrap="square" lIns="0" rIns="0" tIns="0" bIns="0">
+            <a:spAutoFit/>
+          </a:bodyPr>
+          <a:lstStyle/>
+          <a:p>
+            <a:pPr algn="l">
+              <a:lnSpc>
+                <a:spcPct val="115000"/>
+              </a:lnSpc>
+            </a:pPr>
+            <a:r>
+              <a:rPr sz="1500" b="0">
+                <a:solidFill>
+                  <a:srgbClr val="9EABB1"/>
+                </a:solidFill>
+                <a:latin typeface="Inter"/>
+              </a:rPr>
+              <a:t>Voorstel, oktober 2026</a:t>
+            </a:r>
+          </a:p>
+        </p:txBody>
+      </p:sp>
+      <p:sp>
+        <p:nvSpPr>
+          <p:cNvPr id="4" name="TextBox 3"/>
+          <p:cNvSpPr txBox="1"/>
+          <p:nvPr/>
+        </p:nvSpPr>
+        <p:spPr>
+          <a:xfrm>
+            <a:off x="762000" y="2032000"/>
+            <a:ext cx="6096000" cy="889000"/>
+          </a:xfrm>
+          <a:prstGeom prst="rect">
+            <a:avLst/>
+          </a:prstGeom>
+          <a:noFill/>
+        </p:spPr>
+        <p:txBody>
+          <a:bodyPr wrap="square" lIns="0" rIns="0" tIns="0" bIns="0">
+            <a:spAutoFit/>
+          </a:bodyPr>
+          <a:lstStyle/>
+          <a:p>
+            <a:pPr algn="l">
+              <a:lnSpc>
+                <a:spcPct val="98000"/>
+              </a:lnSpc>
+            </a:pPr>
+            <a:r>
+              <a:rPr sz="6600" b="1">
+                <a:solidFill>
+                  <a:srgbClr val="FFFFFF"/>
+                </a:solidFill>
+                <a:latin typeface="League Spartan"/>
+              </a:rPr>
+              <a:t>[Naam]</a:t>
+            </a:r>
+          </a:p>
+        </p:txBody>
+      </p:sp>
+      <p:sp>
+        <p:nvSpPr>
+          <p:cNvPr id="5" name="TextBox 4"/>
+          <p:cNvSpPr txBox="1"/>
+          <p:nvPr/>
+        </p:nvSpPr>
+        <p:spPr>
+          <a:xfrm>
+            <a:off x="762000" y="3175000"/>
+            <a:ext cx="5715000" cy="762000"/>
+          </a:xfrm>
+          <a:prstGeom prst="rect">
+            <a:avLst/>
+          </a:prstGeom>
+          <a:noFill/>
+        </p:spPr>
+        <p:txBody>
+          <a:bodyPr wrap="square" lIns="0" rIns="0" tIns="0" bIns="0">
+            <a:spAutoFit/>
+          </a:bodyPr>
+          <a:lstStyle/>
+          <a:p>
+            <a:pPr algn="l">
+              <a:lnSpc>
+                <a:spcPct val="115000"/>
+              </a:lnSpc>
+            </a:pPr>
+            <a:r>
+              <a:rPr sz="2200" b="0">
+                <a:solidFill>
+                  <a:srgbClr val="9EABB1"/>
+                </a:solidFill>
+                <a:latin typeface="Inter"/>
+              </a:rPr>
+              <a:t>Product designer die ook zelf bouwt, van Figma tot live app.</a:t>
+            </a:r>
+          </a:p>
+        </p:txBody>
+      </p:sp>
+      <p:sp>
+        <p:nvSpPr>
+          <p:cNvPr id="6" name="TextBox 5"/>
+          <p:cNvSpPr txBox="1"/>
+          <p:nvPr/>
+        </p:nvSpPr>
+        <p:spPr>
+          <a:xfrm>
+            <a:off x="762000" y="4445000"/>
+            <a:ext cx="5715000" cy="254000"/>
+          </a:xfrm>
+          <a:prstGeom prst="rect">
+            <a:avLst/>
+          </a:prstGeom>
+          <a:noFill/>
+        </p:spPr>
+        <p:txBody>
+          <a:bodyPr wrap="square" lIns="0" rIns="0" tIns="0" bIns="0">
+            <a:spAutoFit/>
+          </a:bodyPr>
+          <a:lstStyle/>
+          <a:p>
+            <a:pPr algn="l">
+              <a:lnSpc>
+                <a:spcPct val="115000"/>
+              </a:lnSpc>
+            </a:pPr>
+            <a:r>
+              <a:rPr sz="1500" b="0">
+                <a:solidFill>
+                  <a:srgbClr val="9EABB1"/>
+                </a:solidFill>
+                <a:latin typeface="Inter"/>
+              </a:rPr>
+              <a:t>[Opleiding]  ·  woont in Den Haag  ·  30 uur per week</a:t>
+            </a:r>
+          </a:p>
+        </p:txBody>
+      </p:sp>
+      <p:sp>
+        <p:nvSpPr>
+          <p:cNvPr id="7" name="Rounded Rectangle 6"/>
+          <p:cNvSpPr/>
+          <p:nvPr/>
+        </p:nvSpPr>
+        <p:spPr>
+          <a:xfrm>
+            <a:off x="7874000" y="1270000"/>
+            <a:ext cx="3556000" cy="3556000"/>
+          </a:xfrm>
+          <a:prstGeom prst="roundRect">
+            <a:avLst>
+              <a:gd name="adj" fmla="val 3571"/>
+            </a:avLst>
+          </a:prstGeom>
+          <a:solidFill>
+            <a:srgbClr val="163B4C"/>
+          </a:solidFill>
+          <a:ln>
+            <a:noFill/>
+          </a:ln>
+          <a:effectLst/>
+        </p:spPr>
+        <p:style>
+          <a:lnRef idx="1">
+            <a:schemeClr val="accent1"/>
+          </a:lnRef>
+          <a:fillRef idx="3">
+            <a:schemeClr val="accent1"/>
+          </a:fillRef>
+          <a:effectRef idx="2">
+            <a:schemeClr val="accent1"/>
+          </a:effectRef>
+          <a:fontRef idx="minor">
+            <a:schemeClr val="lt1"/>
+          </a:fontRef>
+        </p:style>
+        <p:txBody>
+          <a:bodyPr rtlCol="0" anchor="ctr"/>
+          <a:lstStyle/>
+          <a:p>
+            <a:pPr algn="ctr"/>
+          </a:p>
+        </p:txBody>
+      </p:sp>
+      <p:sp>
+        <p:nvSpPr>
+          <p:cNvPr id="8" name="TextBox 7"/>
+          <p:cNvSpPr txBox="1"/>
+          <p:nvPr/>
+        </p:nvSpPr>
+        <p:spPr>
+          <a:xfrm>
+            <a:off x="7874000" y="2889250"/>
+            <a:ext cx="3556000" cy="317500"/>
+          </a:xfrm>
+          <a:prstGeom prst="rect">
+            <a:avLst/>
+          </a:prstGeom>
+          <a:noFill/>
+        </p:spPr>
+        <p:txBody>
+          <a:bodyPr wrap="square" lIns="0" rIns="0" tIns="0" bIns="0">
+            <a:spAutoFit/>
+          </a:bodyPr>
+          <a:lstStyle/>
+          <a:p>
+            <a:pPr algn="ctr">
+              <a:lnSpc>
+                <a:spcPct val="115000"/>
+              </a:lnSpc>
+            </a:pPr>
+            <a:r>
+              <a:rPr sz="2000" b="0">
+                <a:solidFill>
+                  <a:srgbClr val="9EABB1"/>
+                </a:solidFill>
+                <a:latin typeface="Inter"/>
+              </a:rPr>
+              <a:t>Foto</a:t>
+            </a:r>
+          </a:p>
+        </p:txBody>
+      </p:sp>
+      <p:sp>
+        <p:nvSpPr>
+          <p:cNvPr id="9" name="Rectangle 8"/>
+          <p:cNvSpPr/>
+          <p:nvPr/>
+        </p:nvSpPr>
+        <p:spPr>
+          <a:xfrm>
+            <a:off x="762000" y="5511800"/>
+            <a:ext cx="10668000" cy="6350"/>
+          </a:xfrm>
+          <a:prstGeom prst="rect">
+            <a:avLst/>
+          </a:prstGeom>
+          <a:solidFill>
+            <a:srgbClr val="24475A"/>
+          </a:solidFill>
+          <a:ln>
+            <a:noFill/>
+          </a:ln>
+          <a:effectLst/>
+        </p:spPr>
+        <p:style>
+          <a:lnRef idx="1">
+            <a:schemeClr val="accent1"/>
+          </a:lnRef>
+          <a:fillRef idx="3">
+            <a:schemeClr val="accent1"/>
+          </a:fillRef>
+          <a:effectRef idx="2">
+            <a:schemeClr val="accent1"/>
+          </a:effectRef>
+          <a:fontRef idx="minor">
+            <a:schemeClr val="lt1"/>
+          </a:fontRef>
+        </p:style>
+        <p:txBody>
+          <a:bodyPr rtlCol="0" anchor="ctr"/>
+          <a:lstStyle/>
+          <a:p>
+            <a:pPr algn="ctr"/>
+          </a:p>
+        </p:txBody>
+      </p:sp>
+      <p:pic>
+        <p:nvPicPr>
+          <p:cNvPr id="10" name="Picture 9" descr="logo_white.png"/>
+          <p:cNvPicPr>
+            <a:picLocks noChangeAspect="1"/>
+          </p:cNvPicPr>
+          <p:nvPr/>
+        </p:nvPicPr>
+        <p:blipFill>
+          <a:blip r:embed="rId2"/>
+          <a:stretch>
+            <a:fillRect/>
+          </a:stretch>
+        </p:blipFill>
+        <p:spPr>
+          <a:xfrm>
+            <a:off x="10350500" y="5759450"/>
+            <a:ext cx="1079500" cy="292100"/>
+          </a:xfrm>
+          <a:prstGeom prst="rect">
+            <a:avLst/>
+          </a:prstGeom>
+        </p:spPr>
+      </p:pic>
+      <p:sp>
+        <p:nvSpPr>
+          <p:cNvPr id="11" name="TextBox 10"/>
+          <p:cNvSpPr txBox="1"/>
+          <p:nvPr/>
+        </p:nvSpPr>
+        <p:spPr>
+          <a:xfrm>
+            <a:off x="10795000" y="6375400"/>
+            <a:ext cx="635000" cy="228600"/>
+          </a:xfrm>
+          <a:prstGeom prst="rect">
+            <a:avLst/>
+          </a:prstGeom>
+          <a:noFill/>
+        </p:spPr>
+        <p:txBody>
+          <a:bodyPr wrap="square" lIns="0" rIns="0" tIns="0" bIns="0">
+            <a:spAutoFit/>
+          </a:bodyPr>
+          <a:lstStyle/>
+          <a:p>
+            <a:pPr algn="r">
+              <a:lnSpc>
+                <a:spcPct val="115000"/>
+              </a:lnSpc>
+            </a:pPr>
+            <a:r>
+              <a:rPr sz="1150" b="0">
+                <a:solidFill>
+                  <a:srgbClr val="5E7A88"/>
+                </a:solidFill>
+                <a:latin typeface="Inter"/>
+              </a:rPr>
+              <a:t>1</a:t>
+            </a:r>
+          </a:p>
+        </p:txBody>
+      </p:sp>
+    </p:spTree>
+  </p:cSld>
+  <p:clrMapOvr>
+    <a:masterClrMapping/>
+  </p:clrMapOvr>
+</p:sld>
+</file>
+
+<file path=ppt/slides/slide2.xml><?xml version="1.0" encoding="utf-8"?>
+<p:sld xmlns:a="http://schemas.openxmlformats.org/drawingml/2006/main" xmlns:p="http://schemas.openxmlformats.org/presentationml/2006/main" xmlns:r="http://schemas.openxmlformats.org/officeDocument/2006/relationships">
+  <p:cSld>
+    <p:spTree>
+      <p:nvGrpSpPr>
+        <p:cNvPr id="1" name=""/>
+        <p:cNvGrpSpPr/>
+        <p:nvPr/>
+      </p:nvGrpSpPr>
+      <p:grpSpPr/>
+      <p:sp>
+        <p:nvSpPr>
+          <p:cNvPr id="2" name="TextBox 1"/>
+          <p:cNvSpPr txBox="1"/>
+          <p:nvPr/>
+        </p:nvSpPr>
+        <p:spPr>
+          <a:xfrm>
+            <a:off x="762000" y="558800"/>
+            <a:ext cx="10668000" cy="762000"/>
+          </a:xfrm>
+          <a:prstGeom prst="rect">
+            <a:avLst/>
+          </a:prstGeom>
+          <a:noFill/>
+        </p:spPr>
+        <p:txBody>
+          <a:bodyPr wrap="square" lIns="0" rIns="0" tIns="0" bIns="0">
+            <a:spAutoFit/>
+          </a:bodyPr>
+          <a:lstStyle/>
+          <a:p>
+            <a:pPr algn="ctr">
+              <a:lnSpc>
+                <a:spcPct val="100000"/>
+              </a:lnSpc>
+            </a:pPr>
+            <a:r>
+              <a:rPr sz="4800" b="1">
+                <a:solidFill>
+                  <a:srgbClr val="002333"/>
+                </a:solidFill>
+                <a:latin typeface="League Spartan"/>
+              </a:rPr>
+              <a:t>Ontwerpt het en bouwt het zelf</a:t>
+            </a:r>
+          </a:p>
+        </p:txBody>
+      </p:sp>
+      <p:sp>
+        <p:nvSpPr>
+          <p:cNvPr id="3" name="Rounded Rectangle 2"/>
+          <p:cNvSpPr/>
+          <p:nvPr/>
+        </p:nvSpPr>
+        <p:spPr>
+          <a:xfrm>
+            <a:off x="762000" y="1778000"/>
+            <a:ext cx="812800" cy="812800"/>
+          </a:xfrm>
+          <a:prstGeom prst="roundRect">
+            <a:avLst>
+              <a:gd name="adj" fmla="val 24300"/>
+            </a:avLst>
+          </a:prstGeom>
+          <a:solidFill>
+            <a:srgbClr val="F3F7F8"/>
+          </a:solidFill>
+          <a:ln>
+            <a:noFill/>
+          </a:ln>
+          <a:effectLst/>
+        </p:spPr>
+        <p:style>
+          <a:lnRef idx="1">
+            <a:schemeClr val="accent1"/>
+          </a:lnRef>
+          <a:fillRef idx="3">
+            <a:schemeClr val="accent1"/>
+          </a:fillRef>
+          <a:effectRef idx="2">
+            <a:schemeClr val="accent1"/>
+          </a:effectRef>
+          <a:fontRef idx="minor">
+            <a:schemeClr val="lt1"/>
+          </a:fontRef>
+        </p:style>
+        <p:txBody>
+          <a:bodyPr rtlCol="0" anchor="ctr"/>
+          <a:lstStyle/>
+          <a:p>
+            <a:pPr algn="ctr"/>
+          </a:p>
+        </p:txBody>
+      </p:sp>
+      <p:pic>
+        <p:nvPicPr>
+          <p:cNvPr id="4" name="Picture 3" descr="icon-code-navy.png"/>
+          <p:cNvPicPr>
+            <a:picLocks noChangeAspect="1"/>
+          </p:cNvPicPr>
+          <p:nvPr/>
+        </p:nvPicPr>
+        <p:blipFill>
+          <a:blip r:embed="rId2"/>
+          <a:stretch>
+            <a:fillRect/>
+          </a:stretch>
+        </p:blipFill>
+        <p:spPr>
+          <a:xfrm>
+            <a:off x="965200" y="1981200"/>
+            <a:ext cx="406400" cy="406400"/>
+          </a:xfrm>
+          <a:prstGeom prst="rect">
+            <a:avLst/>
+          </a:prstGeom>
+        </p:spPr>
+      </p:pic>
+      <p:sp>
+        <p:nvSpPr>
+          <p:cNvPr id="5" name="TextBox 4"/>
+          <p:cNvSpPr txBox="1"/>
+          <p:nvPr/>
+        </p:nvSpPr>
+        <p:spPr>
+          <a:xfrm>
+            <a:off x="762000" y="2870200"/>
+            <a:ext cx="3251200" cy="330200"/>
+          </a:xfrm>
+          <a:prstGeom prst="rect">
+            <a:avLst/>
+          </a:prstGeom>
+          <a:noFill/>
+        </p:spPr>
+        <p:txBody>
+          <a:bodyPr wrap="square" lIns="0" rIns="0" tIns="0" bIns="0">
+            <a:spAutoFit/>
+          </a:bodyPr>
+          <a:lstStyle/>
+          <a:p>
+            <a:pPr algn="l">
+              <a:lnSpc>
+                <a:spcPct val="115000"/>
+              </a:lnSpc>
+            </a:pPr>
+            <a:r>
+              <a:rPr sz="2200" b="1">
+                <a:solidFill>
+                  <a:srgbClr val="002333"/>
+                </a:solidFill>
+                <a:latin typeface="League Spartan"/>
+              </a:rPr>
+              <a:t>Eigen app, live</a:t>
+            </a:r>
+          </a:p>
+        </p:txBody>
+      </p:sp>
+      <p:sp>
+        <p:nvSpPr>
+          <p:cNvPr id="6" name="TextBox 5"/>
+          <p:cNvSpPr txBox="1"/>
+          <p:nvPr/>
+        </p:nvSpPr>
+        <p:spPr>
+          <a:xfrm>
+            <a:off x="762000" y="3327400"/>
+            <a:ext cx="3251200" cy="1460500"/>
+          </a:xfrm>
+          <a:prstGeom prst="rect">
+            <a:avLst/>
+          </a:prstGeom>
+          <a:noFill/>
+        </p:spPr>
+        <p:txBody>
+          <a:bodyPr wrap="square" lIns="0" rIns="0" tIns="0" bIns="0">
+            <a:spAutoFit/>
+          </a:bodyPr>
+          <a:lstStyle/>
+          <a:p>
+            <a:pPr algn="l">
+              <a:lnSpc>
+                <a:spcPct val="140000"/>
+              </a:lnSpc>
+            </a:pPr>
+            <a:r>
+              <a:rPr sz="1600" b="0">
+                <a:solidFill>
+                  <a:srgbClr val="002333"/>
+                </a:solidFill>
+                <a:latin typeface="Inter"/>
+              </a:rPr>
+              <a:t>In Figma ontworpen met een eigen design system, gebouwd met een echte login. Draait nu op de telefoon.</a:t>
+            </a:r>
+          </a:p>
+        </p:txBody>
+      </p:sp>
+      <p:sp>
+        <p:nvSpPr>
+          <p:cNvPr id="7" name="Rounded Rectangle 6"/>
+          <p:cNvSpPr/>
+          <p:nvPr/>
+        </p:nvSpPr>
+        <p:spPr>
+          <a:xfrm>
+            <a:off x="4470400" y="1778000"/>
+            <a:ext cx="812800" cy="812800"/>
+          </a:xfrm>
+          <a:prstGeom prst="roundRect">
+            <a:avLst>
+              <a:gd name="adj" fmla="val 24300"/>
+            </a:avLst>
+          </a:prstGeom>
+          <a:solidFill>
+            <a:srgbClr val="F3F7F8"/>
+          </a:solidFill>
+          <a:ln>
+            <a:noFill/>
+          </a:ln>
+          <a:effectLst/>
+        </p:spPr>
+        <p:style>
+          <a:lnRef idx="1">
+            <a:schemeClr val="accent1"/>
+          </a:lnRef>
+          <a:fillRef idx="3">
+            <a:schemeClr val="accent1"/>
+          </a:fillRef>
+          <a:effectRef idx="2">
+            <a:schemeClr val="accent1"/>
+          </a:effectRef>
+          <a:fontRef idx="minor">
+            <a:schemeClr val="lt1"/>
+          </a:fontRef>
+        </p:style>
+        <p:txBody>
+          <a:bodyPr rtlCol="0" anchor="ctr"/>
+          <a:lstStyle/>
+          <a:p>
+            <a:pPr algn="ctr"/>
+          </a:p>
+        </p:txBody>
+      </p:sp>
+      <p:pic>
+        <p:nvPicPr>
+          <p:cNvPr id="8" name="Picture 7" descr="icon-trend-navy.png"/>
+          <p:cNvPicPr>
+            <a:picLocks noChangeAspect="1"/>
+          </p:cNvPicPr>
+          <p:nvPr/>
+        </p:nvPicPr>
+        <p:blipFill>
+          <a:blip r:embed="rId3"/>
+          <a:stretch>
+            <a:fillRect/>
+          </a:stretch>
+        </p:blipFill>
+        <p:spPr>
+          <a:xfrm>
+            <a:off x="4673600" y="1981200"/>
+            <a:ext cx="406400" cy="406400"/>
+          </a:xfrm>
+          <a:prstGeom prst="rect">
+            <a:avLst/>
+          </a:prstGeom>
+        </p:spPr>
+      </p:pic>
+      <p:sp>
+        <p:nvSpPr>
+          <p:cNvPr id="9" name="TextBox 8"/>
+          <p:cNvSpPr txBox="1"/>
+          <p:nvPr/>
+        </p:nvSpPr>
+        <p:spPr>
+          <a:xfrm>
+            <a:off x="4470400" y="2870200"/>
+            <a:ext cx="3251200" cy="330200"/>
+          </a:xfrm>
+          <a:prstGeom prst="rect">
+            <a:avLst/>
+          </a:prstGeom>
+          <a:noFill/>
+        </p:spPr>
+        <p:txBody>
+          <a:bodyPr wrap="square" lIns="0" rIns="0" tIns="0" bIns="0">
+            <a:spAutoFit/>
+          </a:bodyPr>
+          <a:lstStyle/>
+          <a:p>
+            <a:pPr algn="l">
+              <a:lnSpc>
+                <a:spcPct val="115000"/>
+              </a:lnSpc>
+            </a:pPr>
+            <a:r>
+              <a:rPr sz="2200" b="1">
+                <a:solidFill>
+                  <a:srgbClr val="002333"/>
+                </a:solidFill>
+                <a:latin typeface="League Spartan"/>
+              </a:rPr>
+              <a:t>Website in Framer</a:t>
+            </a:r>
+          </a:p>
+        </p:txBody>
+      </p:sp>
+      <p:sp>
+        <p:nvSpPr>
+          <p:cNvPr id="10" name="TextBox 9"/>
+          <p:cNvSpPr txBox="1"/>
+          <p:nvPr/>
+        </p:nvSpPr>
+        <p:spPr>
+          <a:xfrm>
+            <a:off x="4470400" y="3327400"/>
+            <a:ext cx="3251200" cy="1460500"/>
+          </a:xfrm>
+          <a:prstGeom prst="rect">
+            <a:avLst/>
+          </a:prstGeom>
+          <a:noFill/>
+        </p:spPr>
+        <p:txBody>
+          <a:bodyPr wrap="square" lIns="0" rIns="0" tIns="0" bIns="0">
+            <a:spAutoFit/>
+          </a:bodyPr>
+          <a:lstStyle/>
+          <a:p>
+            <a:pPr algn="l">
+              <a:lnSpc>
+                <a:spcPct val="140000"/>
+              </a:lnSpc>
+            </a:pPr>
+            <a:r>
+              <a:rPr sz="1600" b="0">
+                <a:solidFill>
+                  <a:srgbClr val="002333"/>
+                </a:solidFill>
+                <a:latin typeface="Inter"/>
+              </a:rPr>
+              <a:t>Voor een detailingstudio, ontworpen en gebouwd. Volgens de kandidaat 30 tot 40% meer omzet.</a:t>
+            </a:r>
+          </a:p>
+        </p:txBody>
+      </p:sp>
+      <p:sp>
+        <p:nvSpPr>
+          <p:cNvPr id="11" name="Rounded Rectangle 10"/>
+          <p:cNvSpPr/>
+          <p:nvPr/>
+        </p:nvSpPr>
+        <p:spPr>
+          <a:xfrm>
+            <a:off x="8178800" y="1778000"/>
+            <a:ext cx="812800" cy="812800"/>
+          </a:xfrm>
+          <a:prstGeom prst="roundRect">
+            <a:avLst>
+              <a:gd name="adj" fmla="val 24300"/>
+            </a:avLst>
+          </a:prstGeom>
+          <a:solidFill>
+            <a:srgbClr val="F3F7F8"/>
+          </a:solidFill>
+          <a:ln>
+            <a:noFill/>
+          </a:ln>
+          <a:effectLst/>
+        </p:spPr>
+        <p:style>
+          <a:lnRef idx="1">
+            <a:schemeClr val="accent1"/>
+          </a:lnRef>
+          <a:fillRef idx="3">
+            <a:schemeClr val="accent1"/>
+          </a:fillRef>
+          <a:effectRef idx="2">
+            <a:schemeClr val="accent1"/>
+          </a:effectRef>
+          <a:fontRef idx="minor">
+            <a:schemeClr val="lt1"/>
+          </a:fontRef>
+        </p:style>
+        <p:txBody>
+          <a:bodyPr rtlCol="0" anchor="ctr"/>
+          <a:lstStyle/>
+          <a:p>
+            <a:pPr algn="ctr"/>
+          </a:p>
+        </p:txBody>
+      </p:sp>
+      <p:pic>
+        <p:nvPicPr>
+          <p:cNvPr id="12" name="Picture 11" descr="icon-groep-navy.png"/>
+          <p:cNvPicPr>
+            <a:picLocks noChangeAspect="1"/>
+          </p:cNvPicPr>
+          <p:nvPr/>
+        </p:nvPicPr>
+        <p:blipFill>
+          <a:blip r:embed="rId4"/>
+          <a:stretch>
+            <a:fillRect/>
+          </a:stretch>
+        </p:blipFill>
+        <p:spPr>
+          <a:xfrm>
+            <a:off x="8382000" y="1981200"/>
+            <a:ext cx="406400" cy="406400"/>
+          </a:xfrm>
+          <a:prstGeom prst="rect">
+            <a:avLst/>
+          </a:prstGeom>
+        </p:spPr>
+      </p:pic>
+      <p:sp>
+        <p:nvSpPr>
+          <p:cNvPr id="13" name="TextBox 12"/>
+          <p:cNvSpPr txBox="1"/>
+          <p:nvPr/>
+        </p:nvSpPr>
+        <p:spPr>
+          <a:xfrm>
+            <a:off x="8178800" y="2870200"/>
+            <a:ext cx="3251200" cy="330200"/>
+          </a:xfrm>
+          <a:prstGeom prst="rect">
+            <a:avLst/>
+          </a:prstGeom>
+          <a:noFill/>
+        </p:spPr>
+        <p:txBody>
+          <a:bodyPr wrap="square" lIns="0" rIns="0" tIns="0" bIns="0">
+            <a:spAutoFit/>
+          </a:bodyPr>
+          <a:lstStyle/>
+          <a:p>
+            <a:pPr algn="l">
+              <a:lnSpc>
+                <a:spcPct val="115000"/>
+              </a:lnSpc>
+            </a:pPr>
+            <a:r>
+              <a:rPr sz="2200" b="1">
+                <a:solidFill>
+                  <a:srgbClr val="002333"/>
+                </a:solidFill>
+                <a:latin typeface="League Spartan"/>
+              </a:rPr>
+              <a:t>Scouting</a:t>
+            </a:r>
+          </a:p>
+        </p:txBody>
+      </p:sp>
+      <p:sp>
+        <p:nvSpPr>
+          <p:cNvPr id="14" name="TextBox 13"/>
+          <p:cNvSpPr txBox="1"/>
+          <p:nvPr/>
+        </p:nvSpPr>
+        <p:spPr>
+          <a:xfrm>
+            <a:off x="8178800" y="3327400"/>
+            <a:ext cx="3251200" cy="1460500"/>
+          </a:xfrm>
+          <a:prstGeom prst="rect">
+            <a:avLst/>
+          </a:prstGeom>
+          <a:noFill/>
+        </p:spPr>
+        <p:txBody>
+          <a:bodyPr wrap="square" lIns="0" rIns="0" tIns="0" bIns="0">
+            <a:spAutoFit/>
+          </a:bodyPr>
+          <a:lstStyle/>
+          <a:p>
+            <a:pPr algn="l">
+              <a:lnSpc>
+                <a:spcPct val="140000"/>
+              </a:lnSpc>
+            </a:pPr>
+            <a:r>
+              <a:rPr sz="1600" b="0">
+                <a:solidFill>
+                  <a:srgbClr val="002333"/>
+                </a:solidFill>
+                <a:latin typeface="Inter"/>
+              </a:rPr>
+              <a:t>Organiseerde evenementen tot 30.000 bezoekers. Deed ook sponsoring, video en social.</a:t>
+            </a:r>
+          </a:p>
+        </p:txBody>
+      </p:sp>
+      <p:sp>
+        <p:nvSpPr>
+          <p:cNvPr id="15" name="Rectangle 14"/>
+          <p:cNvSpPr/>
+          <p:nvPr/>
+        </p:nvSpPr>
+        <p:spPr>
+          <a:xfrm>
+            <a:off x="762000" y="5511800"/>
+            <a:ext cx="10668000" cy="6350"/>
+          </a:xfrm>
+          <a:prstGeom prst="rect">
+            <a:avLst/>
+          </a:prstGeom>
+          <a:solidFill>
+            <a:srgbClr val="E7EEF0"/>
+          </a:solidFill>
+          <a:ln>
+            <a:noFill/>
+          </a:ln>
+          <a:effectLst/>
+        </p:spPr>
+        <p:style>
+          <a:lnRef idx="1">
+            <a:schemeClr val="accent1"/>
+          </a:lnRef>
+          <a:fillRef idx="3">
+            <a:schemeClr val="accent1"/>
+          </a:fillRef>
+          <a:effectRef idx="2">
+            <a:schemeClr val="accent1"/>
+          </a:effectRef>
+          <a:fontRef idx="minor">
+            <a:schemeClr val="lt1"/>
+          </a:fontRef>
+        </p:style>
+        <p:txBody>
+          <a:bodyPr rtlCol="0" anchor="ctr"/>
+          <a:lstStyle/>
+          <a:p>
+            <a:pPr algn="ctr"/>
+          </a:p>
+        </p:txBody>
+      </p:sp>
+      <p:sp>
+        <p:nvSpPr>
+          <p:cNvPr id="16" name="TextBox 15"/>
+          <p:cNvSpPr txBox="1"/>
+          <p:nvPr/>
+        </p:nvSpPr>
+        <p:spPr>
+          <a:xfrm>
+            <a:off x="762000" y="5791200"/>
+            <a:ext cx="8382000" cy="254000"/>
+          </a:xfrm>
+          <a:prstGeom prst="rect">
+            <a:avLst/>
+          </a:prstGeom>
+          <a:noFill/>
+        </p:spPr>
+        <p:txBody>
+          <a:bodyPr wrap="square" lIns="0" rIns="0" tIns="0" bIns="0">
+            <a:spAutoFit/>
+          </a:bodyPr>
+          <a:lstStyle/>
+          <a:p>
+            <a:pPr algn="l">
+              <a:lnSpc>
+                <a:spcPct val="130000"/>
+              </a:lnSpc>
+            </a:pPr>
+            <a:r>
+              <a:rPr sz="1150" b="0">
+                <a:solidFill>
+                  <a:srgbClr val="5B7480"/>
+                </a:solidFill>
+                <a:latin typeface="Inter"/>
+              </a:rPr>
+              <a:t>Omzetcijfer: eigen opgave van de kandidaat, niet gecontroleerd.</a:t>
+            </a:r>
+          </a:p>
+        </p:txBody>
+      </p:sp>
+      <p:pic>
+        <p:nvPicPr>
+          <p:cNvPr id="17" name="Picture 16" descr="logo_navy.png"/>
+          <p:cNvPicPr>
+            <a:picLocks noChangeAspect="1"/>
+          </p:cNvPicPr>
+          <p:nvPr/>
+        </p:nvPicPr>
+        <p:blipFill>
+          <a:blip r:embed="rId5"/>
+          <a:stretch>
+            <a:fillRect/>
+          </a:stretch>
+        </p:blipFill>
+        <p:spPr>
+          <a:xfrm>
+            <a:off x="10350500" y="5759450"/>
+            <a:ext cx="1079500" cy="292100"/>
+          </a:xfrm>
+          <a:prstGeom prst="rect">
+            <a:avLst/>
+          </a:prstGeom>
+        </p:spPr>
+      </p:pic>
+      <p:sp>
+        <p:nvSpPr>
+          <p:cNvPr id="18" name="TextBox 17"/>
+          <p:cNvSpPr txBox="1"/>
+          <p:nvPr/>
+        </p:nvSpPr>
+        <p:spPr>
+          <a:xfrm>
+            <a:off x="10795000" y="6375400"/>
+            <a:ext cx="635000" cy="228600"/>
+          </a:xfrm>
+          <a:prstGeom prst="rect">
+            <a:avLst/>
+          </a:prstGeom>
+          <a:noFill/>
+        </p:spPr>
+        <p:txBody>
+          <a:bodyPr wrap="square" lIns="0" rIns="0" tIns="0" bIns="0">
+            <a:spAutoFit/>
+          </a:bodyPr>
+          <a:lstStyle/>
+          <a:p>
+            <a:pPr algn="r">
+              <a:lnSpc>
+                <a:spcPct val="115000"/>
+              </a:lnSpc>
+            </a:pPr>
+            <a:r>
+              <a:rPr sz="1150" b="0">
+                <a:solidFill>
+                  <a:srgbClr val="9AAFB8"/>
+                </a:solidFill>
+                <a:latin typeface="Inter"/>
+              </a:rPr>
+              <a:t>2</a:t>
+            </a:r>
+          </a:p>
+        </p:txBody>
+      </p:sp>
+    </p:spTree>
+  </p:cSld>
+  <p:clrMapOvr>
+    <a:masterClrMapping/>
+  </p:clrMapOvr>
+</p:sld>
+</file>
+
+<file path=ppt/slides/slide3.xml><?xml version="1.0" encoding="utf-8"?>
+<p:sld xmlns:a="http://schemas.openxmlformats.org/drawingml/2006/main" xmlns:p="http://schemas.openxmlformats.org/presentationml/2006/main" xmlns:r="http://schemas.openxmlformats.org/officeDocument/2006/relationships">
+  <p:cSld>
+    <p:spTree>
+      <p:nvGrpSpPr>
+        <p:cNvPr id="1" name=""/>
+        <p:cNvGrpSpPr/>
+        <p:nvPr/>
+      </p:nvGrpSpPr>
+      <p:grpSpPr/>
+      <p:sp>
+        <p:nvSpPr>
           <p:cNvPr id="2" name="TextBox 1"/>
           <p:cNvSpPr txBox="1"/>
           <p:nvPr/>
@@ -4592,6 +5653,1279 @@
                 <a:latin typeface="Inter"/>
               </a:rPr>
               <a:t>3</a:t>
+            </a:r>
+          </a:p>
+        </p:txBody>
+      </p:sp>
+    </p:spTree>
+  </p:cSld>
+  <p:clrMapOvr>
+    <a:masterClrMapping/>
+  </p:clrMapOvr>
+</p:sld>
+</file>
+
+<file path=ppt/slides/slide4.xml><?xml version="1.0" encoding="utf-8"?>
+<p:sld xmlns:a="http://schemas.openxmlformats.org/drawingml/2006/main" xmlns:p="http://schemas.openxmlformats.org/presentationml/2006/main" xmlns:r="http://schemas.openxmlformats.org/officeDocument/2006/relationships">
+  <p:cSld>
+    <p:spTree>
+      <p:nvGrpSpPr>
+        <p:cNvPr id="1" name=""/>
+        <p:cNvGrpSpPr/>
+        <p:nvPr/>
+      </p:nvGrpSpPr>
+      <p:grpSpPr/>
+      <p:sp>
+        <p:nvSpPr>
+          <p:cNvPr id="2" name="TextBox 1"/>
+          <p:cNvSpPr txBox="1"/>
+          <p:nvPr/>
+        </p:nvSpPr>
+        <p:spPr>
+          <a:xfrm>
+            <a:off x="762000" y="558800"/>
+            <a:ext cx="10668000" cy="762000"/>
+          </a:xfrm>
+          <a:prstGeom prst="rect">
+            <a:avLst/>
+          </a:prstGeom>
+          <a:noFill/>
+        </p:spPr>
+        <p:txBody>
+          <a:bodyPr wrap="square" lIns="0" rIns="0" tIns="0" bIns="0">
+            <a:spAutoFit/>
+          </a:bodyPr>
+          <a:lstStyle/>
+          <a:p>
+            <a:pPr algn="ctr">
+              <a:lnSpc>
+                <a:spcPct val="100000"/>
+              </a:lnSpc>
+            </a:pPr>
+            <a:r>
+              <a:rPr sz="4800" b="1">
+                <a:solidFill>
+                  <a:srgbClr val="002333"/>
+                </a:solidFill>
+                <a:latin typeface="League Spartan"/>
+              </a:rPr>
+              <a:t>Eerst de Paper Grader</a:t>
+            </a:r>
+          </a:p>
+        </p:txBody>
+      </p:sp>
+      <p:sp>
+        <p:nvSpPr>
+          <p:cNvPr id="3" name="TextBox 2"/>
+          <p:cNvSpPr txBox="1"/>
+          <p:nvPr/>
+        </p:nvSpPr>
+        <p:spPr>
+          <a:xfrm>
+            <a:off x="762000" y="1778000"/>
+            <a:ext cx="5080000" cy="330200"/>
+          </a:xfrm>
+          <a:prstGeom prst="rect">
+            <a:avLst/>
+          </a:prstGeom>
+          <a:noFill/>
+        </p:spPr>
+        <p:txBody>
+          <a:bodyPr wrap="square" lIns="0" rIns="0" tIns="0" bIns="0">
+            <a:spAutoFit/>
+          </a:bodyPr>
+          <a:lstStyle/>
+          <a:p>
+            <a:pPr algn="l">
+              <a:lnSpc>
+                <a:spcPct val="115000"/>
+              </a:lnSpc>
+            </a:pPr>
+            <a:r>
+              <a:rPr sz="2200" b="1">
+                <a:solidFill>
+                  <a:srgbClr val="002333"/>
+                </a:solidFill>
+                <a:latin typeface="League Spartan"/>
+              </a:rPr>
+              <a:t>Focus</a:t>
+            </a:r>
+          </a:p>
+        </p:txBody>
+      </p:sp>
+      <p:sp>
+        <p:nvSpPr>
+          <p:cNvPr id="4" name="TextBox 3"/>
+          <p:cNvSpPr txBox="1"/>
+          <p:nvPr/>
+        </p:nvSpPr>
+        <p:spPr>
+          <a:xfrm>
+            <a:off x="762000" y="2235200"/>
+            <a:ext cx="5080000" cy="1524000"/>
+          </a:xfrm>
+          <a:prstGeom prst="rect">
+            <a:avLst/>
+          </a:prstGeom>
+          <a:noFill/>
+        </p:spPr>
+        <p:txBody>
+          <a:bodyPr wrap="square" lIns="0" rIns="0" tIns="0" bIns="0">
+            <a:spAutoFit/>
+          </a:bodyPr>
+          <a:lstStyle/>
+          <a:p>
+            <a:pPr algn="l">
+              <a:lnSpc>
+                <a:spcPct val="140000"/>
+              </a:lnSpc>
+            </a:pPr>
+            <a:r>
+              <a:rPr sz="1600" b="0">
+                <a:solidFill>
+                  <a:srgbClr val="002333"/>
+                </a:solidFill>
+                <a:latin typeface="Inter"/>
+              </a:rPr>
+              <a:t>De beoordelingsflow van AI Paper Grader en AI Exam Grader. Dat is wat we verkopen. Dante begeleidt, Samuel bouwt na de overdracht.</a:t>
+            </a:r>
+          </a:p>
+        </p:txBody>
+      </p:sp>
+      <p:sp>
+        <p:nvSpPr>
+          <p:cNvPr id="5" name="TextBox 4"/>
+          <p:cNvSpPr txBox="1"/>
+          <p:nvPr/>
+        </p:nvSpPr>
+        <p:spPr>
+          <a:xfrm>
+            <a:off x="6350000" y="1778000"/>
+            <a:ext cx="5080000" cy="330200"/>
+          </a:xfrm>
+          <a:prstGeom prst="rect">
+            <a:avLst/>
+          </a:prstGeom>
+          <a:noFill/>
+        </p:spPr>
+        <p:txBody>
+          <a:bodyPr wrap="square" lIns="0" rIns="0" tIns="0" bIns="0">
+            <a:spAutoFit/>
+          </a:bodyPr>
+          <a:lstStyle/>
+          <a:p>
+            <a:pPr algn="l">
+              <a:lnSpc>
+                <a:spcPct val="115000"/>
+              </a:lnSpc>
+            </a:pPr>
+            <a:r>
+              <a:rPr sz="2200" b="1">
+                <a:solidFill>
+                  <a:srgbClr val="002333"/>
+                </a:solidFill>
+                <a:latin typeface="League Spartan"/>
+              </a:rPr>
+              <a:t>Als er tijd over is</a:t>
+            </a:r>
+          </a:p>
+        </p:txBody>
+      </p:sp>
+      <p:sp>
+        <p:nvSpPr>
+          <p:cNvPr id="6" name="Rounded Rectangle 5"/>
+          <p:cNvSpPr/>
+          <p:nvPr/>
+        </p:nvSpPr>
+        <p:spPr>
+          <a:xfrm>
+            <a:off x="6350000" y="2336800"/>
+            <a:ext cx="76200" cy="76200"/>
+          </a:xfrm>
+          <a:prstGeom prst="roundRect">
+            <a:avLst>
+              <a:gd name="adj" fmla="val 25000"/>
+            </a:avLst>
+          </a:prstGeom>
+          <a:solidFill>
+            <a:srgbClr val="CDD9DE"/>
+          </a:solidFill>
+          <a:ln>
+            <a:noFill/>
+          </a:ln>
+          <a:effectLst/>
+        </p:spPr>
+        <p:style>
+          <a:lnRef idx="1">
+            <a:schemeClr val="accent1"/>
+          </a:lnRef>
+          <a:fillRef idx="3">
+            <a:schemeClr val="accent1"/>
+          </a:fillRef>
+          <a:effectRef idx="2">
+            <a:schemeClr val="accent1"/>
+          </a:effectRef>
+          <a:fontRef idx="minor">
+            <a:schemeClr val="lt1"/>
+          </a:fontRef>
+        </p:style>
+        <p:txBody>
+          <a:bodyPr rtlCol="0" anchor="ctr"/>
+          <a:lstStyle/>
+          <a:p>
+            <a:pPr algn="ctr"/>
+          </a:p>
+        </p:txBody>
+      </p:sp>
+      <p:sp>
+        <p:nvSpPr>
+          <p:cNvPr id="7" name="TextBox 6"/>
+          <p:cNvSpPr txBox="1"/>
+          <p:nvPr/>
+        </p:nvSpPr>
+        <p:spPr>
+          <a:xfrm>
+            <a:off x="6578600" y="2235200"/>
+            <a:ext cx="4826000" cy="279400"/>
+          </a:xfrm>
+          <a:prstGeom prst="rect">
+            <a:avLst/>
+          </a:prstGeom>
+          <a:noFill/>
+        </p:spPr>
+        <p:txBody>
+          <a:bodyPr wrap="square" lIns="0" rIns="0" tIns="0" bIns="0">
+            <a:spAutoFit/>
+          </a:bodyPr>
+          <a:lstStyle/>
+          <a:p>
+            <a:pPr algn="l">
+              <a:lnSpc>
+                <a:spcPct val="115000"/>
+              </a:lnSpc>
+            </a:pPr>
+            <a:r>
+              <a:rPr sz="1600" b="0">
+                <a:solidFill>
+                  <a:srgbClr val="002333"/>
+                </a:solidFill>
+                <a:latin typeface="Inter"/>
+              </a:rPr>
+              <a:t>Waarom gratis gebruikers (PLG) afhaken</a:t>
+            </a:r>
+          </a:p>
+        </p:txBody>
+      </p:sp>
+      <p:sp>
+        <p:nvSpPr>
+          <p:cNvPr id="8" name="Rounded Rectangle 7"/>
+          <p:cNvSpPr/>
+          <p:nvPr/>
+        </p:nvSpPr>
+        <p:spPr>
+          <a:xfrm>
+            <a:off x="6350000" y="2768600"/>
+            <a:ext cx="76200" cy="76200"/>
+          </a:xfrm>
+          <a:prstGeom prst="roundRect">
+            <a:avLst>
+              <a:gd name="adj" fmla="val 25000"/>
+            </a:avLst>
+          </a:prstGeom>
+          <a:solidFill>
+            <a:srgbClr val="CDD9DE"/>
+          </a:solidFill>
+          <a:ln>
+            <a:noFill/>
+          </a:ln>
+          <a:effectLst/>
+        </p:spPr>
+        <p:style>
+          <a:lnRef idx="1">
+            <a:schemeClr val="accent1"/>
+          </a:lnRef>
+          <a:fillRef idx="3">
+            <a:schemeClr val="accent1"/>
+          </a:fillRef>
+          <a:effectRef idx="2">
+            <a:schemeClr val="accent1"/>
+          </a:effectRef>
+          <a:fontRef idx="minor">
+            <a:schemeClr val="lt1"/>
+          </a:fontRef>
+        </p:style>
+        <p:txBody>
+          <a:bodyPr rtlCol="0" anchor="ctr"/>
+          <a:lstStyle/>
+          <a:p>
+            <a:pPr algn="ctr"/>
+          </a:p>
+        </p:txBody>
+      </p:sp>
+      <p:sp>
+        <p:nvSpPr>
+          <p:cNvPr id="9" name="TextBox 8"/>
+          <p:cNvSpPr txBox="1"/>
+          <p:nvPr/>
+        </p:nvSpPr>
+        <p:spPr>
+          <a:xfrm>
+            <a:off x="6578600" y="2667000"/>
+            <a:ext cx="4826000" cy="279400"/>
+          </a:xfrm>
+          <a:prstGeom prst="rect">
+            <a:avLst/>
+          </a:prstGeom>
+          <a:noFill/>
+        </p:spPr>
+        <p:txBody>
+          <a:bodyPr wrap="square" lIns="0" rIns="0" tIns="0" bIns="0">
+            <a:spAutoFit/>
+          </a:bodyPr>
+          <a:lstStyle/>
+          <a:p>
+            <a:pPr algn="l">
+              <a:lnSpc>
+                <a:spcPct val="115000"/>
+              </a:lnSpc>
+            </a:pPr>
+            <a:r>
+              <a:rPr sz="1600" b="0">
+                <a:solidFill>
+                  <a:srgbClr val="002333"/>
+                </a:solidFill>
+                <a:latin typeface="Inter"/>
+              </a:rPr>
+              <a:t>Mailtool kiezen en de mailflow bouwen</a:t>
+            </a:r>
+          </a:p>
+        </p:txBody>
+      </p:sp>
+      <p:sp>
+        <p:nvSpPr>
+          <p:cNvPr id="10" name="Rounded Rectangle 9"/>
+          <p:cNvSpPr/>
+          <p:nvPr/>
+        </p:nvSpPr>
+        <p:spPr>
+          <a:xfrm>
+            <a:off x="6350000" y="3200400"/>
+            <a:ext cx="76200" cy="76200"/>
+          </a:xfrm>
+          <a:prstGeom prst="roundRect">
+            <a:avLst>
+              <a:gd name="adj" fmla="val 25000"/>
+            </a:avLst>
+          </a:prstGeom>
+          <a:solidFill>
+            <a:srgbClr val="CDD9DE"/>
+          </a:solidFill>
+          <a:ln>
+            <a:noFill/>
+          </a:ln>
+          <a:effectLst/>
+        </p:spPr>
+        <p:style>
+          <a:lnRef idx="1">
+            <a:schemeClr val="accent1"/>
+          </a:lnRef>
+          <a:fillRef idx="3">
+            <a:schemeClr val="accent1"/>
+          </a:fillRef>
+          <a:effectRef idx="2">
+            <a:schemeClr val="accent1"/>
+          </a:effectRef>
+          <a:fontRef idx="minor">
+            <a:schemeClr val="lt1"/>
+          </a:fontRef>
+        </p:style>
+        <p:txBody>
+          <a:bodyPr rtlCol="0" anchor="ctr"/>
+          <a:lstStyle/>
+          <a:p>
+            <a:pPr algn="ctr"/>
+          </a:p>
+        </p:txBody>
+      </p:sp>
+      <p:sp>
+        <p:nvSpPr>
+          <p:cNvPr id="11" name="TextBox 10"/>
+          <p:cNvSpPr txBox="1"/>
+          <p:nvPr/>
+        </p:nvSpPr>
+        <p:spPr>
+          <a:xfrm>
+            <a:off x="6578600" y="3098800"/>
+            <a:ext cx="4826000" cy="279400"/>
+          </a:xfrm>
+          <a:prstGeom prst="rect">
+            <a:avLst/>
+          </a:prstGeom>
+          <a:noFill/>
+        </p:spPr>
+        <p:txBody>
+          <a:bodyPr wrap="square" lIns="0" rIns="0" tIns="0" bIns="0">
+            <a:spAutoFit/>
+          </a:bodyPr>
+          <a:lstStyle/>
+          <a:p>
+            <a:pPr algn="l">
+              <a:lnSpc>
+                <a:spcPct val="115000"/>
+              </a:lnSpc>
+            </a:pPr>
+            <a:r>
+              <a:rPr sz="1600" b="0">
+                <a:solidFill>
+                  <a:srgbClr val="002333"/>
+                </a:solidFill>
+                <a:latin typeface="Inter"/>
+              </a:rPr>
+              <a:t>Banners voor beurzen</a:t>
+            </a:r>
+          </a:p>
+        </p:txBody>
+      </p:sp>
+      <p:sp>
+        <p:nvSpPr>
+          <p:cNvPr id="12" name="Rounded Rectangle 11"/>
+          <p:cNvSpPr/>
+          <p:nvPr/>
+        </p:nvSpPr>
+        <p:spPr>
+          <a:xfrm>
+            <a:off x="762000" y="4064000"/>
+            <a:ext cx="10668000" cy="1066800"/>
+          </a:xfrm>
+          <a:prstGeom prst="roundRect">
+            <a:avLst>
+              <a:gd name="adj" fmla="val 11904"/>
+            </a:avLst>
+          </a:prstGeom>
+          <a:solidFill>
+            <a:srgbClr val="F3F7F8"/>
+          </a:solidFill>
+          <a:ln>
+            <a:noFill/>
+          </a:ln>
+          <a:effectLst/>
+        </p:spPr>
+        <p:style>
+          <a:lnRef idx="1">
+            <a:schemeClr val="accent1"/>
+          </a:lnRef>
+          <a:fillRef idx="3">
+            <a:schemeClr val="accent1"/>
+          </a:fillRef>
+          <a:effectRef idx="2">
+            <a:schemeClr val="accent1"/>
+          </a:effectRef>
+          <a:fontRef idx="minor">
+            <a:schemeClr val="lt1"/>
+          </a:fontRef>
+        </p:style>
+        <p:txBody>
+          <a:bodyPr rtlCol="0" anchor="ctr"/>
+          <a:lstStyle/>
+          <a:p>
+            <a:pPr algn="ctr"/>
+          </a:p>
+        </p:txBody>
+      </p:sp>
+      <p:sp>
+        <p:nvSpPr>
+          <p:cNvPr id="13" name="TextBox 12"/>
+          <p:cNvSpPr txBox="1"/>
+          <p:nvPr/>
+        </p:nvSpPr>
+        <p:spPr>
+          <a:xfrm>
+            <a:off x="1066800" y="4292600"/>
+            <a:ext cx="10058400" cy="635000"/>
+          </a:xfrm>
+          <a:prstGeom prst="rect">
+            <a:avLst/>
+          </a:prstGeom>
+          <a:noFill/>
+        </p:spPr>
+        <p:txBody>
+          <a:bodyPr wrap="square" lIns="0" rIns="0" tIns="0" bIns="0">
+            <a:spAutoFit/>
+          </a:bodyPr>
+          <a:lstStyle/>
+          <a:p>
+            <a:pPr algn="l">
+              <a:lnSpc>
+                <a:spcPct val="140000"/>
+              </a:lnSpc>
+            </a:pPr>
+            <a:r>
+              <a:rPr sz="1600" b="0">
+                <a:solidFill>
+                  <a:srgbClr val="002333"/>
+                </a:solidFill>
+                <a:latin typeface="Inter"/>
+              </a:rPr>
+              <a:t>Pluspunt: elke woensdag feedback van docenten op de eigen opleiding. Gratis gebruikersonderzoek bij precies onze doelgroep.</a:t>
+            </a:r>
+          </a:p>
+        </p:txBody>
+      </p:sp>
+      <p:sp>
+        <p:nvSpPr>
+          <p:cNvPr id="14" name="Rectangle 13"/>
+          <p:cNvSpPr/>
+          <p:nvPr/>
+        </p:nvSpPr>
+        <p:spPr>
+          <a:xfrm>
+            <a:off x="762000" y="5511800"/>
+            <a:ext cx="10668000" cy="6350"/>
+          </a:xfrm>
+          <a:prstGeom prst="rect">
+            <a:avLst/>
+          </a:prstGeom>
+          <a:solidFill>
+            <a:srgbClr val="E7EEF0"/>
+          </a:solidFill>
+          <a:ln>
+            <a:noFill/>
+          </a:ln>
+          <a:effectLst/>
+        </p:spPr>
+        <p:style>
+          <a:lnRef idx="1">
+            <a:schemeClr val="accent1"/>
+          </a:lnRef>
+          <a:fillRef idx="3">
+            <a:schemeClr val="accent1"/>
+          </a:fillRef>
+          <a:effectRef idx="2">
+            <a:schemeClr val="accent1"/>
+          </a:effectRef>
+          <a:fontRef idx="minor">
+            <a:schemeClr val="lt1"/>
+          </a:fontRef>
+        </p:style>
+        <p:txBody>
+          <a:bodyPr rtlCol="0" anchor="ctr"/>
+          <a:lstStyle/>
+          <a:p>
+            <a:pPr algn="ctr"/>
+          </a:p>
+        </p:txBody>
+      </p:sp>
+      <p:pic>
+        <p:nvPicPr>
+          <p:cNvPr id="15" name="Picture 14" descr="logo_navy.png"/>
+          <p:cNvPicPr>
+            <a:picLocks noChangeAspect="1"/>
+          </p:cNvPicPr>
+          <p:nvPr/>
+        </p:nvPicPr>
+        <p:blipFill>
+          <a:blip r:embed="rId2"/>
+          <a:stretch>
+            <a:fillRect/>
+          </a:stretch>
+        </p:blipFill>
+        <p:spPr>
+          <a:xfrm>
+            <a:off x="10350500" y="5759450"/>
+            <a:ext cx="1079500" cy="292100"/>
+          </a:xfrm>
+          <a:prstGeom prst="rect">
+            <a:avLst/>
+          </a:prstGeom>
+        </p:spPr>
+      </p:pic>
+      <p:sp>
+        <p:nvSpPr>
+          <p:cNvPr id="16" name="TextBox 15"/>
+          <p:cNvSpPr txBox="1"/>
+          <p:nvPr/>
+        </p:nvSpPr>
+        <p:spPr>
+          <a:xfrm>
+            <a:off x="10795000" y="6375400"/>
+            <a:ext cx="635000" cy="228600"/>
+          </a:xfrm>
+          <a:prstGeom prst="rect">
+            <a:avLst/>
+          </a:prstGeom>
+          <a:noFill/>
+        </p:spPr>
+        <p:txBody>
+          <a:bodyPr wrap="square" lIns="0" rIns="0" tIns="0" bIns="0">
+            <a:spAutoFit/>
+          </a:bodyPr>
+          <a:lstStyle/>
+          <a:p>
+            <a:pPr algn="r">
+              <a:lnSpc>
+                <a:spcPct val="115000"/>
+              </a:lnSpc>
+            </a:pPr>
+            <a:r>
+              <a:rPr sz="1150" b="0">
+                <a:solidFill>
+                  <a:srgbClr val="9AAFB8"/>
+                </a:solidFill>
+                <a:latin typeface="Inter"/>
+              </a:rPr>
+              <a:t>4</a:t>
+            </a:r>
+          </a:p>
+        </p:txBody>
+      </p:sp>
+    </p:spTree>
+  </p:cSld>
+  <p:clrMapOvr>
+    <a:masterClrMapping/>
+  </p:clrMapOvr>
+</p:sld>
+</file>
+
+<file path=ppt/slides/slide5.xml><?xml version="1.0" encoding="utf-8"?>
+<p:sld xmlns:a="http://schemas.openxmlformats.org/drawingml/2006/main" xmlns:p="http://schemas.openxmlformats.org/presentationml/2006/main" xmlns:r="http://schemas.openxmlformats.org/officeDocument/2006/relationships">
+  <p:cSld>
+    <p:spTree>
+      <p:nvGrpSpPr>
+        <p:cNvPr id="1" name=""/>
+        <p:cNvGrpSpPr/>
+        <p:nvPr/>
+      </p:nvGrpSpPr>
+      <p:grpSpPr/>
+      <p:sp>
+        <p:nvSpPr>
+          <p:cNvPr id="2" name="Rectangle 1"/>
+          <p:cNvSpPr/>
+          <p:nvPr/>
+        </p:nvSpPr>
+        <p:spPr>
+          <a:xfrm>
+            <a:off x="0" y="0"/>
+            <a:ext cx="12192000" cy="6858000"/>
+          </a:xfrm>
+          <a:prstGeom prst="rect">
+            <a:avLst/>
+          </a:prstGeom>
+          <a:solidFill>
+            <a:srgbClr val="002333"/>
+          </a:solidFill>
+          <a:ln>
+            <a:noFill/>
+          </a:ln>
+          <a:effectLst/>
+        </p:spPr>
+        <p:style>
+          <a:lnRef idx="1">
+            <a:schemeClr val="accent1"/>
+          </a:lnRef>
+          <a:fillRef idx="3">
+            <a:schemeClr val="accent1"/>
+          </a:fillRef>
+          <a:effectRef idx="2">
+            <a:schemeClr val="accent1"/>
+          </a:effectRef>
+          <a:fontRef idx="minor">
+            <a:schemeClr val="lt1"/>
+          </a:fontRef>
+        </p:style>
+        <p:txBody>
+          <a:bodyPr rtlCol="0" anchor="ctr"/>
+          <a:lstStyle/>
+          <a:p>
+            <a:pPr algn="ctr"/>
+          </a:p>
+        </p:txBody>
+      </p:sp>
+      <p:sp>
+        <p:nvSpPr>
+          <p:cNvPr id="3" name="TextBox 2"/>
+          <p:cNvSpPr txBox="1"/>
+          <p:nvPr/>
+        </p:nvSpPr>
+        <p:spPr>
+          <a:xfrm>
+            <a:off x="762000" y="558800"/>
+            <a:ext cx="10668000" cy="762000"/>
+          </a:xfrm>
+          <a:prstGeom prst="rect">
+            <a:avLst/>
+          </a:prstGeom>
+          <a:noFill/>
+        </p:spPr>
+        <p:txBody>
+          <a:bodyPr wrap="square" lIns="0" rIns="0" tIns="0" bIns="0">
+            <a:spAutoFit/>
+          </a:bodyPr>
+          <a:lstStyle/>
+          <a:p>
+            <a:pPr algn="ctr">
+              <a:lnSpc>
+                <a:spcPct val="100000"/>
+              </a:lnSpc>
+            </a:pPr>
+            <a:r>
+              <a:rPr sz="4800" b="1">
+                <a:solidFill>
+                  <a:srgbClr val="FFFFFF"/>
+                </a:solidFill>
+                <a:latin typeface="League Spartan"/>
+              </a:rPr>
+              <a:t>Beslissen voor woensdag</a:t>
+            </a:r>
+          </a:p>
+        </p:txBody>
+      </p:sp>
+      <p:sp>
+        <p:nvSpPr>
+          <p:cNvPr id="4" name="TextBox 3"/>
+          <p:cNvSpPr txBox="1"/>
+          <p:nvPr/>
+        </p:nvSpPr>
+        <p:spPr>
+          <a:xfrm>
+            <a:off x="762000" y="1841500"/>
+            <a:ext cx="3556000" cy="330200"/>
+          </a:xfrm>
+          <a:prstGeom prst="rect">
+            <a:avLst/>
+          </a:prstGeom>
+          <a:noFill/>
+        </p:spPr>
+        <p:txBody>
+          <a:bodyPr wrap="square" lIns="0" rIns="0" tIns="0" bIns="0">
+            <a:spAutoFit/>
+          </a:bodyPr>
+          <a:lstStyle/>
+          <a:p>
+            <a:pPr algn="l">
+              <a:lnSpc>
+                <a:spcPct val="115000"/>
+              </a:lnSpc>
+            </a:pPr>
+            <a:r>
+              <a:rPr sz="2200" b="1">
+                <a:solidFill>
+                  <a:srgbClr val="FFFFFF"/>
+                </a:solidFill>
+                <a:latin typeface="League Spartan"/>
+              </a:rPr>
+              <a:t>Gaan we het doen?</a:t>
+            </a:r>
+          </a:p>
+        </p:txBody>
+      </p:sp>
+      <p:sp>
+        <p:nvSpPr>
+          <p:cNvPr id="5" name="TextBox 4"/>
+          <p:cNvSpPr txBox="1"/>
+          <p:nvPr/>
+        </p:nvSpPr>
+        <p:spPr>
+          <a:xfrm>
+            <a:off x="4572000" y="1866900"/>
+            <a:ext cx="6858000" cy="609600"/>
+          </a:xfrm>
+          <a:prstGeom prst="rect">
+            <a:avLst/>
+          </a:prstGeom>
+          <a:noFill/>
+        </p:spPr>
+        <p:txBody>
+          <a:bodyPr wrap="square" lIns="0" rIns="0" tIns="0" bIns="0">
+            <a:spAutoFit/>
+          </a:bodyPr>
+          <a:lstStyle/>
+          <a:p>
+            <a:pPr algn="l">
+              <a:lnSpc>
+                <a:spcPct val="135000"/>
+              </a:lnSpc>
+            </a:pPr>
+            <a:r>
+              <a:rPr sz="1600" b="0">
+                <a:solidFill>
+                  <a:srgbClr val="9EABB1"/>
+                </a:solidFill>
+                <a:latin typeface="Inter"/>
+              </a:rPr>
+              <a:t>Akkoord nodig uiterlijk wo 7 oktober, anders kan het sprintvoorstel niet op tijd in.</a:t>
+            </a:r>
+          </a:p>
+        </p:txBody>
+      </p:sp>
+      <p:sp>
+        <p:nvSpPr>
+          <p:cNvPr id="6" name="Rectangle 5"/>
+          <p:cNvSpPr/>
+          <p:nvPr/>
+        </p:nvSpPr>
+        <p:spPr>
+          <a:xfrm>
+            <a:off x="762000" y="2527300"/>
+            <a:ext cx="10668000" cy="6350"/>
+          </a:xfrm>
+          <a:prstGeom prst="rect">
+            <a:avLst/>
+          </a:prstGeom>
+          <a:solidFill>
+            <a:srgbClr val="24475A"/>
+          </a:solidFill>
+          <a:ln>
+            <a:noFill/>
+          </a:ln>
+          <a:effectLst/>
+        </p:spPr>
+        <p:style>
+          <a:lnRef idx="1">
+            <a:schemeClr val="accent1"/>
+          </a:lnRef>
+          <a:fillRef idx="3">
+            <a:schemeClr val="accent1"/>
+          </a:fillRef>
+          <a:effectRef idx="2">
+            <a:schemeClr val="accent1"/>
+          </a:effectRef>
+          <a:fontRef idx="minor">
+            <a:schemeClr val="lt1"/>
+          </a:fontRef>
+        </p:style>
+        <p:txBody>
+          <a:bodyPr rtlCol="0" anchor="ctr"/>
+          <a:lstStyle/>
+          <a:p>
+            <a:pPr algn="ctr"/>
+          </a:p>
+        </p:txBody>
+      </p:sp>
+      <p:sp>
+        <p:nvSpPr>
+          <p:cNvPr id="7" name="TextBox 6"/>
+          <p:cNvSpPr txBox="1"/>
+          <p:nvPr/>
+        </p:nvSpPr>
+        <p:spPr>
+          <a:xfrm>
+            <a:off x="762000" y="2705100"/>
+            <a:ext cx="3556000" cy="330200"/>
+          </a:xfrm>
+          <a:prstGeom prst="rect">
+            <a:avLst/>
+          </a:prstGeom>
+          <a:noFill/>
+        </p:spPr>
+        <p:txBody>
+          <a:bodyPr wrap="square" lIns="0" rIns="0" tIns="0" bIns="0">
+            <a:spAutoFit/>
+          </a:bodyPr>
+          <a:lstStyle/>
+          <a:p>
+            <a:pPr algn="l">
+              <a:lnSpc>
+                <a:spcPct val="115000"/>
+              </a:lnSpc>
+            </a:pPr>
+            <a:r>
+              <a:rPr sz="2200" b="1">
+                <a:solidFill>
+                  <a:srgbClr val="FFFFFF"/>
+                </a:solidFill>
+                <a:latin typeface="League Spartan"/>
+              </a:rPr>
+              <a:t>Vergoeding</a:t>
+            </a:r>
+          </a:p>
+        </p:txBody>
+      </p:sp>
+      <p:sp>
+        <p:nvSpPr>
+          <p:cNvPr id="8" name="TextBox 7"/>
+          <p:cNvSpPr txBox="1"/>
+          <p:nvPr/>
+        </p:nvSpPr>
+        <p:spPr>
+          <a:xfrm>
+            <a:off x="4572000" y="2730500"/>
+            <a:ext cx="6858000" cy="609600"/>
+          </a:xfrm>
+          <a:prstGeom prst="rect">
+            <a:avLst/>
+          </a:prstGeom>
+          <a:noFill/>
+        </p:spPr>
+        <p:txBody>
+          <a:bodyPr wrap="square" lIns="0" rIns="0" tIns="0" bIns="0">
+            <a:spAutoFit/>
+          </a:bodyPr>
+          <a:lstStyle/>
+          <a:p>
+            <a:pPr algn="l">
+              <a:lnSpc>
+                <a:spcPct val="135000"/>
+              </a:lnSpc>
+            </a:pPr>
+            <a:r>
+              <a:rPr sz="1600" b="0">
+                <a:solidFill>
+                  <a:srgbClr val="9EABB1"/>
+                </a:solidFill>
+                <a:latin typeface="Inter"/>
+              </a:rPr>
+              <a:t>Nog open. De kandidaat staat open voor een lager begin, bijstellen op basis van het werk.</a:t>
+            </a:r>
+          </a:p>
+        </p:txBody>
+      </p:sp>
+      <p:sp>
+        <p:nvSpPr>
+          <p:cNvPr id="9" name="Rectangle 8"/>
+          <p:cNvSpPr/>
+          <p:nvPr/>
+        </p:nvSpPr>
+        <p:spPr>
+          <a:xfrm>
+            <a:off x="762000" y="3390900"/>
+            <a:ext cx="10668000" cy="6350"/>
+          </a:xfrm>
+          <a:prstGeom prst="rect">
+            <a:avLst/>
+          </a:prstGeom>
+          <a:solidFill>
+            <a:srgbClr val="24475A"/>
+          </a:solidFill>
+          <a:ln>
+            <a:noFill/>
+          </a:ln>
+          <a:effectLst/>
+        </p:spPr>
+        <p:style>
+          <a:lnRef idx="1">
+            <a:schemeClr val="accent1"/>
+          </a:lnRef>
+          <a:fillRef idx="3">
+            <a:schemeClr val="accent1"/>
+          </a:fillRef>
+          <a:effectRef idx="2">
+            <a:schemeClr val="accent1"/>
+          </a:effectRef>
+          <a:fontRef idx="minor">
+            <a:schemeClr val="lt1"/>
+          </a:fontRef>
+        </p:style>
+        <p:txBody>
+          <a:bodyPr rtlCol="0" anchor="ctr"/>
+          <a:lstStyle/>
+          <a:p>
+            <a:pPr algn="ctr"/>
+          </a:p>
+        </p:txBody>
+      </p:sp>
+      <p:sp>
+        <p:nvSpPr>
+          <p:cNvPr id="10" name="TextBox 9"/>
+          <p:cNvSpPr txBox="1"/>
+          <p:nvPr/>
+        </p:nvSpPr>
+        <p:spPr>
+          <a:xfrm>
+            <a:off x="762000" y="3568700"/>
+            <a:ext cx="3556000" cy="330200"/>
+          </a:xfrm>
+          <a:prstGeom prst="rect">
+            <a:avLst/>
+          </a:prstGeom>
+          <a:noFill/>
+        </p:spPr>
+        <p:txBody>
+          <a:bodyPr wrap="square" lIns="0" rIns="0" tIns="0" bIns="0">
+            <a:spAutoFit/>
+          </a:bodyPr>
+          <a:lstStyle/>
+          <a:p>
+            <a:pPr algn="l">
+              <a:lnSpc>
+                <a:spcPct val="115000"/>
+              </a:lnSpc>
+            </a:pPr>
+            <a:r>
+              <a:rPr sz="2200" b="1">
+                <a:solidFill>
+                  <a:srgbClr val="FFFFFF"/>
+                </a:solidFill>
+                <a:latin typeface="League Spartan"/>
+              </a:rPr>
+              <a:t>Tweede gesprek</a:t>
+            </a:r>
+          </a:p>
+        </p:txBody>
+      </p:sp>
+      <p:sp>
+        <p:nvSpPr>
+          <p:cNvPr id="11" name="TextBox 10"/>
+          <p:cNvSpPr txBox="1"/>
+          <p:nvPr/>
+        </p:nvSpPr>
+        <p:spPr>
+          <a:xfrm>
+            <a:off x="4572000" y="3594100"/>
+            <a:ext cx="6858000" cy="609600"/>
+          </a:xfrm>
+          <a:prstGeom prst="rect">
+            <a:avLst/>
+          </a:prstGeom>
+          <a:noFill/>
+        </p:spPr>
+        <p:txBody>
+          <a:bodyPr wrap="square" lIns="0" rIns="0" tIns="0" bIns="0">
+            <a:spAutoFit/>
+          </a:bodyPr>
+          <a:lstStyle/>
+          <a:p>
+            <a:pPr algn="l">
+              <a:lnSpc>
+                <a:spcPct val="135000"/>
+              </a:lnSpc>
+            </a:pPr>
+            <a:r>
+              <a:rPr sz="1600" b="0">
+                <a:solidFill>
+                  <a:srgbClr val="9EABB1"/>
+                </a:solidFill>
+                <a:latin typeface="Inter"/>
+              </a:rPr>
+              <a:t>Met Jeroen en Menno, online of in Leiden.</a:t>
+            </a:r>
+          </a:p>
+        </p:txBody>
+      </p:sp>
+      <p:sp>
+        <p:nvSpPr>
+          <p:cNvPr id="12" name="Rectangle 11"/>
+          <p:cNvSpPr/>
+          <p:nvPr/>
+        </p:nvSpPr>
+        <p:spPr>
+          <a:xfrm>
+            <a:off x="762000" y="4254500"/>
+            <a:ext cx="10668000" cy="6350"/>
+          </a:xfrm>
+          <a:prstGeom prst="rect">
+            <a:avLst/>
+          </a:prstGeom>
+          <a:solidFill>
+            <a:srgbClr val="24475A"/>
+          </a:solidFill>
+          <a:ln>
+            <a:noFill/>
+          </a:ln>
+          <a:effectLst/>
+        </p:spPr>
+        <p:style>
+          <a:lnRef idx="1">
+            <a:schemeClr val="accent1"/>
+          </a:lnRef>
+          <a:fillRef idx="3">
+            <a:schemeClr val="accent1"/>
+          </a:fillRef>
+          <a:effectRef idx="2">
+            <a:schemeClr val="accent1"/>
+          </a:effectRef>
+          <a:fontRef idx="minor">
+            <a:schemeClr val="lt1"/>
+          </a:fontRef>
+        </p:style>
+        <p:txBody>
+          <a:bodyPr rtlCol="0" anchor="ctr"/>
+          <a:lstStyle/>
+          <a:p>
+            <a:pPr algn="ctr"/>
+          </a:p>
+        </p:txBody>
+      </p:sp>
+      <p:sp>
+        <p:nvSpPr>
+          <p:cNvPr id="13" name="TextBox 12"/>
+          <p:cNvSpPr txBox="1"/>
+          <p:nvPr/>
+        </p:nvSpPr>
+        <p:spPr>
+          <a:xfrm>
+            <a:off x="762000" y="4432300"/>
+            <a:ext cx="3556000" cy="330200"/>
+          </a:xfrm>
+          <a:prstGeom prst="rect">
+            <a:avLst/>
+          </a:prstGeom>
+          <a:noFill/>
+        </p:spPr>
+        <p:txBody>
+          <a:bodyPr wrap="square" lIns="0" rIns="0" tIns="0" bIns="0">
+            <a:spAutoFit/>
+          </a:bodyPr>
+          <a:lstStyle/>
+          <a:p>
+            <a:pPr algn="l">
+              <a:lnSpc>
+                <a:spcPct val="115000"/>
+              </a:lnSpc>
+            </a:pPr>
+            <a:r>
+              <a:rPr sz="2200" b="1">
+                <a:solidFill>
+                  <a:srgbClr val="FFFFFF"/>
+                </a:solidFill>
+                <a:latin typeface="League Spartan"/>
+              </a:rPr>
+              <a:t>Geheimhouding</a:t>
+            </a:r>
+          </a:p>
+        </p:txBody>
+      </p:sp>
+      <p:sp>
+        <p:nvSpPr>
+          <p:cNvPr id="14" name="TextBox 13"/>
+          <p:cNvSpPr txBox="1"/>
+          <p:nvPr/>
+        </p:nvSpPr>
+        <p:spPr>
+          <a:xfrm>
+            <a:off x="4572000" y="4457700"/>
+            <a:ext cx="6858000" cy="609600"/>
+          </a:xfrm>
+          <a:prstGeom prst="rect">
+            <a:avLst/>
+          </a:prstGeom>
+          <a:noFill/>
+        </p:spPr>
+        <p:txBody>
+          <a:bodyPr wrap="square" lIns="0" rIns="0" tIns="0" bIns="0">
+            <a:spAutoFit/>
+          </a:bodyPr>
+          <a:lstStyle/>
+          <a:p>
+            <a:pPr algn="l">
+              <a:lnSpc>
+                <a:spcPct val="135000"/>
+              </a:lnSpc>
+            </a:pPr>
+            <a:r>
+              <a:rPr sz="1600" b="0">
+                <a:solidFill>
+                  <a:srgbClr val="9EABB1"/>
+                </a:solidFill>
+                <a:latin typeface="Inter"/>
+              </a:rPr>
+              <a:t>Werkt met echte inleveringen van studenten. Afspraak nodig, ligt bij Jeroen.</a:t>
+            </a:r>
+          </a:p>
+        </p:txBody>
+      </p:sp>
+      <p:sp>
+        <p:nvSpPr>
+          <p:cNvPr id="15" name="Rectangle 14"/>
+          <p:cNvSpPr/>
+          <p:nvPr/>
+        </p:nvSpPr>
+        <p:spPr>
+          <a:xfrm>
+            <a:off x="762000" y="5511800"/>
+            <a:ext cx="10668000" cy="6350"/>
+          </a:xfrm>
+          <a:prstGeom prst="rect">
+            <a:avLst/>
+          </a:prstGeom>
+          <a:solidFill>
+            <a:srgbClr val="24475A"/>
+          </a:solidFill>
+          <a:ln>
+            <a:noFill/>
+          </a:ln>
+          <a:effectLst/>
+        </p:spPr>
+        <p:style>
+          <a:lnRef idx="1">
+            <a:schemeClr val="accent1"/>
+          </a:lnRef>
+          <a:fillRef idx="3">
+            <a:schemeClr val="accent1"/>
+          </a:fillRef>
+          <a:effectRef idx="2">
+            <a:schemeClr val="accent1"/>
+          </a:effectRef>
+          <a:fontRef idx="minor">
+            <a:schemeClr val="lt1"/>
+          </a:fontRef>
+        </p:style>
+        <p:txBody>
+          <a:bodyPr rtlCol="0" anchor="ctr"/>
+          <a:lstStyle/>
+          <a:p>
+            <a:pPr algn="ctr"/>
+          </a:p>
+        </p:txBody>
+      </p:sp>
+      <p:pic>
+        <p:nvPicPr>
+          <p:cNvPr id="16" name="Picture 15" descr="logo_white.png"/>
+          <p:cNvPicPr>
+            <a:picLocks noChangeAspect="1"/>
+          </p:cNvPicPr>
+          <p:nvPr/>
+        </p:nvPicPr>
+        <p:blipFill>
+          <a:blip r:embed="rId2"/>
+          <a:stretch>
+            <a:fillRect/>
+          </a:stretch>
+        </p:blipFill>
+        <p:spPr>
+          <a:xfrm>
+            <a:off x="10350500" y="5759450"/>
+            <a:ext cx="1079500" cy="292100"/>
+          </a:xfrm>
+          <a:prstGeom prst="rect">
+            <a:avLst/>
+          </a:prstGeom>
+        </p:spPr>
+      </p:pic>
+      <p:sp>
+        <p:nvSpPr>
+          <p:cNvPr id="17" name="TextBox 16"/>
+          <p:cNvSpPr txBox="1"/>
+          <p:nvPr/>
+        </p:nvSpPr>
+        <p:spPr>
+          <a:xfrm>
+            <a:off x="10795000" y="6375400"/>
+            <a:ext cx="635000" cy="228600"/>
+          </a:xfrm>
+          <a:prstGeom prst="rect">
+            <a:avLst/>
+          </a:prstGeom>
+          <a:noFill/>
+        </p:spPr>
+        <p:txBody>
+          <a:bodyPr wrap="square" lIns="0" rIns="0" tIns="0" bIns="0">
+            <a:spAutoFit/>
+          </a:bodyPr>
+          <a:lstStyle/>
+          <a:p>
+            <a:pPr algn="r">
+              <a:lnSpc>
+                <a:spcPct val="115000"/>
+              </a:lnSpc>
+            </a:pPr>
+            <a:r>
+              <a:rPr sz="1150" b="0">
+                <a:solidFill>
+                  <a:srgbClr val="5E7A88"/>
+                </a:solidFill>
+                <a:latin typeface="Inter"/>
+              </a:rPr>
+              <a:t>5</a:t>
             </a:r>
           </a:p>
         </p:txBody>

</xml_diff>